<commit_message>
Update Notion workspace URL to david-data.notion.site
- Updated author page with new shortened Notion domain
- Changed all references from open-baryonyx-afb.notion.site to david-data.notion.site
</commit_message>
<xml_diff>
--- a/iFood's Campaign Budget Misdirection.pptx
+++ b/iFood's Campaign Budget Misdirection.pptx
@@ -4,6 +4,9 @@
   <p:sldMasterIdLst>
     <p:sldMasterId id="2147483648" r:id="rId1"/>
   </p:sldMasterIdLst>
+  <p:notesMasterIdLst>
+    <p:notesMasterId r:id="rId10"/>
+  </p:notesMasterIdLst>
   <p:sldIdLst>
     <p:sldId id="256" r:id="rId2"/>
     <p:sldId id="257" r:id="rId3"/>
@@ -14,9 +17,6 @@
     <p:sldId id="262" r:id="rId8"/>
     <p:sldId id="263" r:id="rId9"/>
   </p:sldIdLst>
-  <p:notesMasterIdLst>
-    <p:notesMasterId r:id="rId10"/>
-  </p:notesMasterIdLst>
   <p:sldSz cx="18288000" cy="10287000"/>
   <p:notesSz cx="10287000" cy="18288000"/>
   <p:defaultTextStyle>
@@ -111,6 +111,11 @@
       </a:defRPr>
     </a:lvl9pPr>
   </p:defaultTextStyle>
+  <p:extLst>
+    <p:ext uri="{EFAFB233-063F-42B5-8137-9DF3F51BA10A}">
+      <p15:sldGuideLst xmlns:p15="http://schemas.microsoft.com/office/powerpoint/2012/main"/>
+    </p:ext>
+  </p:extLst>
 </p:presentation>
 </file>
 
@@ -136,234 +141,10 @@
           <a:chExt cx="0" cy="0"/>
         </a:xfrm>
       </p:grpSpPr>
-      <p:sp>
-        <p:nvSpPr>
-          <p:cNvPr id="2" name="Header Placeholder 1"/>
-          <p:cNvSpPr>
-            <a:spLocks noGrp="1"/>
-          </p:cNvSpPr>
-          <p:nvPr>
-            <p:ph type="hdr" sz="quarter"/>
-          </p:nvPr>
-        </p:nvSpPr>
-        <p:spPr>
-          <a:xfrm>
-            <a:off x="0" y="0"/>
-            <a:ext cx="2971800" cy="458788"/>
-          </a:xfrm>
-          <a:prstGeom prst="rect">
-            <a:avLst/>
-          </a:prstGeom>
-        </p:spPr>
-        <p:txBody>
-          <a:bodyPr vert="horz" lIns="91440" tIns="45720" rIns="91440" bIns="45720" rtlCol="0"/>
-          <a:lstStyle>
-            <a:lvl1pPr algn="l">
-              <a:defRPr sz="1200"/>
-            </a:lvl1pPr>
-          </a:lstStyle>
-          <a:p>
-            <a:endParaRPr lang="en-US"/>
-          </a:p>
-        </p:txBody>
-      </p:sp>
-      <p:sp>
-        <p:nvSpPr>
-          <p:cNvPr id="3" name="Date Placeholder 2"/>
-          <p:cNvSpPr>
-            <a:spLocks noGrp="1"/>
-          </p:cNvSpPr>
-          <p:nvPr>
-            <p:ph type="dt" idx="1"/>
-          </p:nvPr>
-        </p:nvSpPr>
-        <p:spPr>
-          <a:xfrm>
-            <a:off x="3884613" y="0"/>
-            <a:ext cx="2971800" cy="458788"/>
-          </a:xfrm>
-          <a:prstGeom prst="rect">
-            <a:avLst/>
-          </a:prstGeom>
-        </p:spPr>
-        <p:txBody>
-          <a:bodyPr vert="horz" lIns="91440" tIns="45720" rIns="91440" bIns="45720" rtlCol="0"/>
-          <a:lstStyle>
-            <a:lvl1pPr algn="r">
-              <a:defRPr sz="1200"/>
-            </a:lvl1pPr>
-          </a:lstStyle>
-          <a:p>
-            <a:fld id="{5282F153-3F37-0F45-9E97-73ACFA13230C}" type="datetimeFigureOut">
-              <a:rPr lang="en-US"/>
-              <a:t>7/23/19</a:t>
-            </a:fld>
-            <a:endParaRPr lang="en-US"/>
-          </a:p>
-        </p:txBody>
-      </p:sp>
-      <p:sp>
-        <p:nvSpPr>
-          <p:cNvPr id="4" name="Slide Image Placeholder 3"/>
-          <p:cNvSpPr>
-            <a:spLocks noGrp="1" noRot="1" noChangeAspect="1"/>
-          </p:cNvSpPr>
-          <p:nvPr>
-            <p:ph type="sldImg" idx="2"/>
-          </p:nvPr>
-        </p:nvSpPr>
-        <p:spPr>
-          <a:xfrm>
-            <a:off x="685800" y="1143000"/>
-            <a:ext cx="5486400" cy="3086100"/>
-          </a:xfrm>
-          <a:prstGeom prst="rect">
-            <a:avLst/>
-          </a:prstGeom>
-          <a:noFill/>
-          <a:ln w="12700">
-            <a:solidFill>
-              <a:prstClr val="black"/>
-            </a:solidFill>
-          </a:ln>
-        </p:spPr>
-        <p:txBody>
-          <a:bodyPr vert="horz" lIns="91440" tIns="45720" rIns="91440" bIns="45720" rtlCol="0" anchor="ctr"/>
-          <a:lstStyle/>
-          <a:p>
-            <a:endParaRPr lang="en-US"/>
-          </a:p>
-        </p:txBody>
-      </p:sp>
-      <p:sp>
-        <p:nvSpPr>
-          <p:cNvPr id="5" name="Notes Placeholder 4"/>
-          <p:cNvSpPr>
-            <a:spLocks noGrp="1"/>
-          </p:cNvSpPr>
-          <p:nvPr>
-            <p:ph type="body" sz="quarter" idx="3"/>
-          </p:nvPr>
-        </p:nvSpPr>
-        <p:spPr>
-          <a:xfrm>
-            <a:off x="685800" y="4400550"/>
-            <a:ext cx="5486400" cy="3600450"/>
-          </a:xfrm>
-          <a:prstGeom prst="rect">
-            <a:avLst/>
-          </a:prstGeom>
-        </p:spPr>
-        <p:txBody>
-          <a:bodyPr vert="horz" lIns="91440" tIns="45720" rIns="91440" bIns="45720" rtlCol="0"/>
-          <a:lstStyle/>
-          <a:p>
-            <a:pPr lvl="0"/>
-            <a:r>
-              <a:rPr lang="en-US"/>
-              <a:t>Click to edit Master text styles</a:t>
-            </a:r>
-          </a:p>
-          <a:p>
-            <a:pPr lvl="1"/>
-            <a:r>
-              <a:rPr lang="en-US"/>
-              <a:t>Second level</a:t>
-            </a:r>
-          </a:p>
-          <a:p>
-            <a:pPr lvl="2"/>
-            <a:r>
-              <a:rPr lang="en-US"/>
-              <a:t>Third level</a:t>
-            </a:r>
-          </a:p>
-          <a:p>
-            <a:pPr lvl="3"/>
-            <a:r>
-              <a:rPr lang="en-US"/>
-              <a:t>Fourth level</a:t>
-            </a:r>
-          </a:p>
-          <a:p>
-            <a:pPr lvl="4"/>
-            <a:r>
-              <a:rPr lang="en-US"/>
-              <a:t>Fifth level</a:t>
-            </a:r>
-          </a:p>
-        </p:txBody>
-      </p:sp>
-      <p:sp>
-        <p:nvSpPr>
-          <p:cNvPr id="6" name="Footer Placeholder 5"/>
-          <p:cNvSpPr>
-            <a:spLocks noGrp="1"/>
-          </p:cNvSpPr>
-          <p:nvPr>
-            <p:ph type="ftr" sz="quarter" idx="4"/>
-          </p:nvPr>
-        </p:nvSpPr>
-        <p:spPr>
-          <a:xfrm>
-            <a:off x="0" y="8685213"/>
-            <a:ext cx="2971800" cy="458787"/>
-          </a:xfrm>
-          <a:prstGeom prst="rect">
-            <a:avLst/>
-          </a:prstGeom>
-        </p:spPr>
-        <p:txBody>
-          <a:bodyPr vert="horz" lIns="91440" tIns="45720" rIns="91440" bIns="45720" rtlCol="0" anchor="b"/>
-          <a:lstStyle>
-            <a:lvl1pPr algn="l">
-              <a:defRPr sz="1200"/>
-            </a:lvl1pPr>
-          </a:lstStyle>
-          <a:p>
-            <a:endParaRPr lang="en-US"/>
-          </a:p>
-        </p:txBody>
-      </p:sp>
-      <p:sp>
-        <p:nvSpPr>
-          <p:cNvPr id="7" name="Slide Number Placeholder 6"/>
-          <p:cNvSpPr>
-            <a:spLocks noGrp="1"/>
-          </p:cNvSpPr>
-          <p:nvPr>
-            <p:ph type="sldNum" sz="quarter" idx="5"/>
-          </p:nvPr>
-        </p:nvSpPr>
-        <p:spPr>
-          <a:xfrm>
-            <a:off x="3884613" y="8685213"/>
-            <a:ext cx="2971800" cy="458787"/>
-          </a:xfrm>
-          <a:prstGeom prst="rect">
-            <a:avLst/>
-          </a:prstGeom>
-        </p:spPr>
-        <p:txBody>
-          <a:bodyPr vert="horz" lIns="91440" tIns="45720" rIns="91440" bIns="45720" rtlCol="0" anchor="b"/>
-          <a:lstStyle>
-            <a:lvl1pPr algn="r">
-              <a:defRPr sz="1200"/>
-            </a:lvl1pPr>
-          </a:lstStyle>
-          <a:p>
-            <a:fld id="{CE5E9CC1-C706-0F49-92D6-E571CC5EEA8F}" type="slidenum">
-              <a:rPr lang="en-US"/>
-              <a:t>‹#›</a:t>
-            </a:fld>
-            <a:endParaRPr lang="en-US"/>
-          </a:p>
-        </p:txBody>
-      </p:sp>
     </p:spTree>
     <p:extLst>
       <p:ext uri="{BB962C8B-B14F-4D97-AF65-F5344CB8AC3E}">
-        <p14:creationId xmlns:p14="http://schemas.microsoft.com/office/powerpoint/2010/main" val="1024086991"/>
+        <p14:creationId xmlns:p14="http://schemas.microsoft.com/office/powerpoint/2010/main" val="549715684"/>
       </p:ext>
     </p:extLst>
   </p:cSld>
@@ -511,7 +292,6 @@
               <a:rPr lang="en-US" dirty="0"/>
               <a:t>This is a campaign-strategy review, not a data dump. The argument: the last five campaigns should not be the template for the next one.</a:t>
             </a:r>
-            <a:endParaRPr lang="en-US" dirty="0"/>
           </a:p>
         </p:txBody>
       </p:sp>
@@ -599,7 +379,6 @@
               <a:rPr lang="en-US" dirty="0"/>
               <a:t>Everyone asks who responded. The question worth paying for is whether the next campaign should look like the last five.</a:t>
             </a:r>
-            <a:endParaRPr lang="en-US" dirty="0"/>
           </a:p>
         </p:txBody>
       </p:sp>
@@ -687,7 +466,6 @@
               <a:rPr lang="en-US" dirty="0"/>
               <a:t>The core claim. The campaign engine sends one message to everyone. But the base is not uniform — and the gaps are large enough to move budget on.</a:t>
             </a:r>
-            <a:endParaRPr lang="en-US" dirty="0"/>
           </a:p>
         </p:txBody>
       </p:sp>
@@ -775,7 +553,6 @@
               <a:rPr lang="en-US" dirty="0"/>
               <a:t>The 40-49 bracket is the largest and least responsive at 16.4%. The 18-29 bracket is the smallest and converts at 32.6% — double. Budget is flowing to volume, not propensity.</a:t>
             </a:r>
-            <a:endParaRPr lang="en-US" dirty="0"/>
           </a:p>
         </p:txBody>
       </p:sp>
@@ -863,7 +640,6 @@
               <a:rPr lang="en-US" dirty="0"/>
               <a:t>Kids collapse browsing behaviour. Catalog and store use drop; deal use more than doubles. Catalog mailed to a family is mostly wasted print.</a:t>
             </a:r>
-            <a:endParaRPr lang="en-US" dirty="0"/>
           </a:p>
         </p:txBody>
       </p:sp>
@@ -951,7 +727,6 @@
               <a:rPr lang="en-US" dirty="0"/>
               <a:t>Wine scales ~60x with income and works as an income proxy. Below 30k, meat outspends wine — the only bracket where necessity beats discretionary. Premium wine offers there just generate irritation.</a:t>
             </a:r>
-            <a:endParaRPr lang="en-US" dirty="0"/>
           </a:p>
         </p:txBody>
       </p:sp>
@@ -1039,7 +814,6 @@
               <a:rPr lang="en-US" dirty="0"/>
               <a:t>Three moves, ordered by implementation cost. None needs new data — every field already exists.</a:t>
             </a:r>
-            <a:endParaRPr lang="en-US" dirty="0"/>
           </a:p>
         </p:txBody>
       </p:sp>
@@ -1127,7 +901,6 @@
               <a:rPr lang="en-US" dirty="0"/>
               <a:t>The cost of the current approach is invisible because it shows up as mediocre average acceptance, not a line item. That is exactly why segment-level analysis is worth running first.</a:t>
             </a:r>
-            <a:endParaRPr lang="en-US" dirty="0"/>
           </a:p>
         </p:txBody>
       </p:sp>
@@ -1200,6 +973,11 @@
 <file path=ppt/slideMasters/slideMaster1.xml><?xml version="1.0" encoding="utf-8"?>
 <p:sldMaster xmlns:a="http://schemas.openxmlformats.org/drawingml/2006/main" xmlns:r="http://schemas.openxmlformats.org/officeDocument/2006/relationships" xmlns:p="http://schemas.openxmlformats.org/presentationml/2006/main">
   <p:cSld>
+    <p:bg>
+      <p:bgRef idx="1001">
+        <a:schemeClr val="bg1"/>
+      </p:bgRef>
+    </p:bg>
     <p:spTree>
       <p:nvGrpSpPr>
         <p:cNvPr id="1" name=""/>
@@ -1482,6 +1260,7 @@
         <a:solidFill>
           <a:srgbClr val="0E1726"/>
         </a:solidFill>
+        <a:effectLst/>
       </p:bgPr>
     </p:bg>
     <p:spTree>
@@ -1517,6 +1296,13 @@
           </a:solidFill>
           <a:ln/>
         </p:spPr>
+        <p:txBody>
+          <a:bodyPr/>
+          <a:lstStyle/>
+          <a:p>
+            <a:endParaRPr lang="en-GB"/>
+          </a:p>
+        </p:txBody>
       </p:sp>
       <p:sp>
         <p:nvSpPr>
@@ -1541,11 +1327,11 @@
           </a:bodyPr>
           <a:lstStyle/>
           <a:p>
-            <a:pPr algn="l" indent="0" marL="0">
-              <a:buNone/>
-            </a:pPr>
-            <a:r>
-              <a:rPr lang="en-US" sz="1800" b="1" spc="396" kern="0" dirty="0">
+            <a:pPr marL="0" indent="0" algn="l">
+              <a:buNone/>
+            </a:pPr>
+            <a:r>
+              <a:rPr lang="en-US" sz="1800" b="1" kern="0" spc="396" dirty="0">
                 <a:solidFill>
                   <a:srgbClr val="93B4FB"/>
                 </a:solidFill>
@@ -1582,14 +1368,14 @@
           </a:bodyPr>
           <a:lstStyle/>
           <a:p>
-            <a:pPr algn="l" indent="0" marL="0">
+            <a:pPr marL="0" indent="0" algn="l">
               <a:lnSpc>
                 <a:spcPct val="98000"/>
               </a:lnSpc>
               <a:buNone/>
             </a:pPr>
             <a:r>
-              <a:rPr lang="en-US" sz="9900" b="1" spc="-297" kern="0" dirty="0">
+              <a:rPr lang="en-US" sz="9900" b="1" kern="0" spc="-297" dirty="0">
                 <a:solidFill>
                   <a:srgbClr val="FFFFFF"/>
                 </a:solidFill>
@@ -1626,7 +1412,7 @@
           </a:bodyPr>
           <a:lstStyle/>
           <a:p>
-            <a:pPr algn="l" indent="0" marL="0">
+            <a:pPr marL="0" indent="0" algn="l">
               <a:lnSpc>
                 <a:spcPct val="130000"/>
               </a:lnSpc>
@@ -1666,6 +1452,13 @@
           </a:solidFill>
           <a:ln/>
         </p:spPr>
+        <p:txBody>
+          <a:bodyPr/>
+          <a:lstStyle/>
+          <a:p>
+            <a:endParaRPr lang="en-GB"/>
+          </a:p>
+        </p:txBody>
       </p:sp>
       <p:sp>
         <p:nvSpPr>
@@ -1690,11 +1483,11 @@
           </a:bodyPr>
           <a:lstStyle/>
           <a:p>
-            <a:pPr algn="l" indent="0" marL="0">
-              <a:buNone/>
-            </a:pPr>
-            <a:r>
-              <a:rPr lang="en-US" sz="1800" spc="54" kern="0" dirty="0">
+            <a:pPr marL="0" indent="0" algn="l">
+              <a:buNone/>
+            </a:pPr>
+            <a:r>
+              <a:rPr lang="en-US" sz="1800" kern="0" spc="54" dirty="0">
                 <a:solidFill>
                   <a:srgbClr val="E2E8F0"/>
                 </a:solidFill>
@@ -1731,11 +1524,11 @@
           </a:bodyPr>
           <a:lstStyle/>
           <a:p>
-            <a:pPr algn="l" indent="0" marL="0">
-              <a:buNone/>
-            </a:pPr>
-            <a:r>
-              <a:rPr lang="en-US" sz="1800" spc="54" kern="0" dirty="0">
+            <a:pPr marL="0" indent="0" algn="l">
+              <a:buNone/>
+            </a:pPr>
+            <a:r>
+              <a:rPr lang="en-US" sz="1800" kern="0" spc="54" dirty="0">
                 <a:solidFill>
                   <a:srgbClr val="64748B"/>
                 </a:solidFill>
@@ -1772,11 +1565,11 @@
           </a:bodyPr>
           <a:lstStyle/>
           <a:p>
-            <a:pPr algn="l" indent="0" marL="0">
-              <a:buNone/>
-            </a:pPr>
-            <a:r>
-              <a:rPr lang="en-US" sz="1800" spc="54" kern="0" dirty="0">
+            <a:pPr marL="0" indent="0" algn="l">
+              <a:buNone/>
+            </a:pPr>
+            <a:r>
+              <a:rPr lang="en-US" sz="1800" kern="0" spc="54" dirty="0">
                 <a:solidFill>
                   <a:srgbClr val="64748B"/>
                 </a:solidFill>
@@ -1806,6 +1599,7 @@
         <a:solidFill>
           <a:srgbClr val="F8FAFC"/>
         </a:solidFill>
+        <a:effectLst/>
       </p:bgPr>
     </p:bg>
     <p:spTree>
@@ -1830,7 +1624,7 @@
         </p:nvSpPr>
         <p:spPr>
           <a:xfrm>
-            <a:off x="1238250" y="2832894"/>
+            <a:off x="1238250" y="2171133"/>
             <a:ext cx="17392650" cy="336550"/>
           </a:xfrm>
           <a:prstGeom prst="rect">
@@ -1845,11 +1639,11 @@
           </a:bodyPr>
           <a:lstStyle/>
           <a:p>
-            <a:pPr algn="l" indent="0" marL="0">
-              <a:buNone/>
-            </a:pPr>
-            <a:r>
-              <a:rPr lang="en-US" sz="1800" b="1" spc="324" kern="0" dirty="0">
+            <a:pPr marL="0" indent="0" algn="l">
+              <a:buNone/>
+            </a:pPr>
+            <a:r>
+              <a:rPr lang="en-US" sz="1800" b="1" kern="0" spc="324" dirty="0">
                 <a:solidFill>
                   <a:srgbClr val="2563EB"/>
                 </a:solidFill>
@@ -1871,29 +1665,29 @@
         </p:nvSpPr>
         <p:spPr>
           <a:xfrm>
-            <a:off x="1238250" y="3550444"/>
-            <a:ext cx="10476041" cy="1903413"/>
-          </a:xfrm>
-          <a:prstGeom prst="rect">
-            <a:avLst/>
-          </a:prstGeom>
-          <a:noFill/>
-          <a:ln/>
-        </p:spPr>
-        <p:txBody>
-          <a:bodyPr wrap="square" lIns="25400" tIns="25400" rIns="25400" bIns="25400" rtlCol="0" anchor="t">
-            <a:normAutofit/>
-          </a:bodyPr>
-          <a:lstStyle/>
-          <a:p>
-            <a:pPr algn="l" indent="0" marL="0">
+            <a:off x="1238250" y="2757487"/>
+            <a:ext cx="9807121" cy="3325019"/>
+          </a:xfrm>
+          <a:prstGeom prst="rect">
+            <a:avLst/>
+          </a:prstGeom>
+          <a:noFill/>
+          <a:ln/>
+        </p:spPr>
+        <p:txBody>
+          <a:bodyPr wrap="square" lIns="25400" tIns="25400" rIns="25400" bIns="25400" rtlCol="0" anchor="t">
+            <a:normAutofit lnSpcReduction="10000"/>
+          </a:bodyPr>
+          <a:lstStyle/>
+          <a:p>
+            <a:pPr marL="0" indent="0" algn="l">
               <a:lnSpc>
                 <a:spcPct val="102000"/>
               </a:lnSpc>
               <a:buNone/>
             </a:pPr>
             <a:r>
-              <a:rPr lang="en-US" sz="7200" b="1" spc="-180" kern="0" dirty="0">
+              <a:rPr lang="en-US" sz="7200" b="1" kern="0" spc="-180" dirty="0">
                 <a:solidFill>
                   <a:srgbClr val="0E1726"/>
                 </a:solidFill>
@@ -1930,7 +1724,7 @@
           </a:bodyPr>
           <a:lstStyle/>
           <a:p>
-            <a:pPr algn="l" indent="0" marL="0">
+            <a:pPr marL="0" indent="0" algn="l">
               <a:lnSpc>
                 <a:spcPct val="150000"/>
               </a:lnSpc>
@@ -1947,107 +1741,83 @@
               </a:rPr>
               <a:t>The obvious question is </a:t>
             </a:r>
-            <a:pPr algn="l" indent="0" marL="0">
+            <a:r>
+              <a:rPr lang="en-US" sz="2400" b="1" dirty="0">
+                <a:solidFill>
+                  <a:srgbClr val="0E1726"/>
+                </a:solidFill>
+                <a:latin typeface="Arial" pitchFamily="34" charset="0"/>
+                <a:ea typeface="Arial" pitchFamily="34" charset="-122"/>
+                <a:cs typeface="Arial" pitchFamily="34" charset="-120"/>
+              </a:rPr>
+              <a:t>who responded </a:t>
+            </a:r>
+            <a:r>
+              <a:rPr lang="en-US" sz="2400" dirty="0">
+                <a:solidFill>
+                  <a:srgbClr val="475569"/>
+                </a:solidFill>
+                <a:latin typeface="Arial" pitchFamily="34" charset="0"/>
+                <a:ea typeface="Arial" pitchFamily="34" charset="-122"/>
+                <a:cs typeface="Arial" pitchFamily="34" charset="-120"/>
+              </a:rPr>
+              <a:t>. The data answers it easily — demographics, household, income, spend, channel.</a:t>
+            </a:r>
+            <a:endParaRPr lang="en-US" sz="2400" dirty="0"/>
+          </a:p>
+        </p:txBody>
+      </p:sp>
+      <p:sp>
+        <p:nvSpPr>
+          <p:cNvPr id="5" name="Text 3"/>
+          <p:cNvSpPr/>
+          <p:nvPr/>
+        </p:nvSpPr>
+        <p:spPr>
+          <a:xfrm>
+            <a:off x="8667750" y="6082507"/>
+            <a:ext cx="7063740" cy="1409700"/>
+          </a:xfrm>
+          <a:prstGeom prst="rect">
+            <a:avLst/>
+          </a:prstGeom>
+          <a:noFill/>
+          <a:ln/>
+        </p:spPr>
+        <p:txBody>
+          <a:bodyPr wrap="square" lIns="25400" tIns="25400" rIns="25400" bIns="25400" rtlCol="0" anchor="t">
+            <a:normAutofit/>
+          </a:bodyPr>
+          <a:lstStyle/>
+          <a:p>
+            <a:pPr marL="0" indent="0" algn="l">
               <a:lnSpc>
                 <a:spcPct val="150000"/>
               </a:lnSpc>
               <a:buNone/>
             </a:pPr>
             <a:r>
-              <a:rPr lang="en-US" sz="2400" b="1" dirty="0">
-                <a:solidFill>
-                  <a:srgbClr val="0E1726"/>
+              <a:rPr lang="en-US" sz="2400" dirty="0">
+                <a:solidFill>
+                  <a:srgbClr val="475569"/>
                 </a:solidFill>
                 <a:latin typeface="Arial" pitchFamily="34" charset="0"/>
                 <a:ea typeface="Arial" pitchFamily="34" charset="-122"/>
                 <a:cs typeface="Arial" pitchFamily="34" charset="-120"/>
               </a:rPr>
-              <a:t>who responded </a:t>
-            </a:r>
-            <a:pPr algn="l" indent="0" marL="0">
-              <a:lnSpc>
-                <a:spcPct val="150000"/>
-              </a:lnSpc>
-              <a:buNone/>
-            </a:pPr>
-            <a:r>
-              <a:rPr lang="en-US" sz="2400" dirty="0">
-                <a:solidFill>
-                  <a:srgbClr val="475569"/>
+              <a:t>The question a manager actually pays for is different: </a:t>
+            </a:r>
+            <a:r>
+              <a:rPr lang="en-US" sz="2400" b="1" dirty="0">
+                <a:solidFill>
+                  <a:srgbClr val="0E1726"/>
                 </a:solidFill>
                 <a:latin typeface="Arial" pitchFamily="34" charset="0"/>
                 <a:ea typeface="Arial" pitchFamily="34" charset="-122"/>
                 <a:cs typeface="Arial" pitchFamily="34" charset="-120"/>
               </a:rPr>
-              <a:t>. The data answers it easily — demographics, household, income, spend, channel.</a:t>
-            </a:r>
-            <a:endParaRPr lang="en-US" sz="2400" dirty="0"/>
-          </a:p>
-        </p:txBody>
-      </p:sp>
-      <p:sp>
-        <p:nvSpPr>
-          <p:cNvPr id="5" name="Text 3"/>
-          <p:cNvSpPr/>
-          <p:nvPr/>
-        </p:nvSpPr>
-        <p:spPr>
-          <a:xfrm>
-            <a:off x="8667750" y="6082507"/>
-            <a:ext cx="7063740" cy="1409700"/>
-          </a:xfrm>
-          <a:prstGeom prst="rect">
-            <a:avLst/>
-          </a:prstGeom>
-          <a:noFill/>
-          <a:ln/>
-        </p:spPr>
-        <p:txBody>
-          <a:bodyPr wrap="square" lIns="25400" tIns="25400" rIns="25400" bIns="25400" rtlCol="0" anchor="t">
-            <a:normAutofit/>
-          </a:bodyPr>
-          <a:lstStyle/>
-          <a:p>
-            <a:pPr algn="l" indent="0" marL="0">
-              <a:lnSpc>
-                <a:spcPct val="150000"/>
-              </a:lnSpc>
-              <a:buNone/>
-            </a:pPr>
-            <a:r>
-              <a:rPr lang="en-US" sz="2400" dirty="0">
-                <a:solidFill>
-                  <a:srgbClr val="475569"/>
-                </a:solidFill>
-                <a:latin typeface="Arial" pitchFamily="34" charset="0"/>
-                <a:ea typeface="Arial" pitchFamily="34" charset="-122"/>
-                <a:cs typeface="Arial" pitchFamily="34" charset="-120"/>
-              </a:rPr>
-              <a:t>The question a manager actually pays for is different: </a:t>
-            </a:r>
-            <a:pPr algn="l" indent="0" marL="0">
-              <a:lnSpc>
-                <a:spcPct val="150000"/>
-              </a:lnSpc>
-              <a:buNone/>
-            </a:pPr>
-            <a:r>
-              <a:rPr lang="en-US" sz="2400" b="1" dirty="0">
-                <a:solidFill>
-                  <a:srgbClr val="0E1726"/>
-                </a:solidFill>
-                <a:latin typeface="Arial" pitchFamily="34" charset="0"/>
-                <a:ea typeface="Arial" pitchFamily="34" charset="-122"/>
-                <a:cs typeface="Arial" pitchFamily="34" charset="-120"/>
-              </a:rPr>
               <a:t>should the next campaign look like the last five? </a:t>
             </a:r>
-            <a:pPr algn="l" indent="0" marL="0">
-              <a:lnSpc>
-                <a:spcPct val="150000"/>
-              </a:lnSpc>
-              <a:buNone/>
-            </a:pPr>
             <a:r>
               <a:rPr lang="en-US" sz="2400" dirty="0">
                 <a:solidFill>
@@ -2079,6 +1849,7 @@
         <a:solidFill>
           <a:srgbClr val="0E1726"/>
         </a:solidFill>
+        <a:effectLst/>
       </p:bgPr>
     </p:bg>
     <p:spTree>
@@ -2118,11 +1889,11 @@
           </a:bodyPr>
           <a:lstStyle/>
           <a:p>
-            <a:pPr algn="l" indent="0" marL="0">
-              <a:buNone/>
-            </a:pPr>
-            <a:r>
-              <a:rPr lang="en-US" sz="1800" b="1" spc="324" kern="0" dirty="0">
+            <a:pPr marL="0" indent="0" algn="l">
+              <a:buNone/>
+            </a:pPr>
+            <a:r>
+              <a:rPr lang="en-US" sz="1800" b="1" kern="0" spc="324" dirty="0">
                 <a:solidFill>
                   <a:srgbClr val="93B4FB"/>
                 </a:solidFill>
@@ -2159,14 +1930,14 @@
           </a:bodyPr>
           <a:lstStyle/>
           <a:p>
-            <a:pPr algn="l" indent="0" marL="0">
+            <a:pPr marL="0" indent="0" algn="l">
               <a:lnSpc>
                 <a:spcPct val="112000"/>
               </a:lnSpc>
               <a:buNone/>
             </a:pPr>
             <a:r>
-              <a:rPr lang="en-US" sz="6600" b="1" spc="-132" kern="0" dirty="0">
+              <a:rPr lang="en-US" sz="6600" b="1" kern="0" spc="-132" dirty="0">
                 <a:solidFill>
                   <a:srgbClr val="FFFFFF"/>
                 </a:solidFill>
@@ -2176,14 +1947,8 @@
               </a:rPr>
               <a:t>The engine treats the customer base as </a:t>
             </a:r>
-            <a:pPr algn="l" indent="0" marL="0">
-              <a:lnSpc>
-                <a:spcPct val="112000"/>
-              </a:lnSpc>
-              <a:buNone/>
-            </a:pPr>
-            <a:r>
-              <a:rPr lang="en-US" sz="6600" b="1" spc="-132" kern="0" dirty="0">
+            <a:r>
+              <a:rPr lang="en-US" sz="6600" b="1" kern="0" spc="-132" dirty="0">
                 <a:solidFill>
                   <a:srgbClr val="93B4FB"/>
                 </a:solidFill>
@@ -2193,14 +1958,8 @@
               </a:rPr>
               <a:t>uniform </a:t>
             </a:r>
-            <a:pPr algn="l" indent="0" marL="0">
-              <a:lnSpc>
-                <a:spcPct val="112000"/>
-              </a:lnSpc>
-              <a:buNone/>
-            </a:pPr>
-            <a:r>
-              <a:rPr lang="en-US" sz="6600" b="1" spc="-132" kern="0" dirty="0">
+            <a:r>
+              <a:rPr lang="en-US" sz="6600" b="1" kern="0" spc="-132" dirty="0">
                 <a:solidFill>
                   <a:srgbClr val="FFFFFF"/>
                 </a:solidFill>
@@ -2237,7 +1996,7 @@
           </a:bodyPr>
           <a:lstStyle/>
           <a:p>
-            <a:pPr algn="l" indent="0" marL="0">
+            <a:pPr marL="0" indent="0" algn="l">
               <a:lnSpc>
                 <a:spcPct val="145000"/>
               </a:lnSpc>
@@ -2274,6 +2033,7 @@
         <a:solidFill>
           <a:srgbClr val="F8FAFC"/>
         </a:solidFill>
+        <a:effectLst/>
       </p:bgPr>
     </p:bg>
     <p:spTree>
@@ -2313,11 +2073,11 @@
           </a:bodyPr>
           <a:lstStyle/>
           <a:p>
-            <a:pPr algn="l" indent="0" marL="0">
-              <a:buNone/>
-            </a:pPr>
-            <a:r>
-              <a:rPr lang="en-US" sz="1800" b="1" spc="324" kern="0" dirty="0">
+            <a:pPr marL="0" indent="0" algn="l">
+              <a:buNone/>
+            </a:pPr>
+            <a:r>
+              <a:rPr lang="en-US" sz="1800" b="1" kern="0" spc="324" dirty="0">
                 <a:solidFill>
                   <a:srgbClr val="2563EB"/>
                 </a:solidFill>
@@ -2354,7 +2114,7 @@
           </a:bodyPr>
           <a:lstStyle/>
           <a:p>
-            <a:pPr algn="l" indent="0" marL="0">
+            <a:pPr marL="0" indent="0" algn="l">
               <a:buNone/>
             </a:pPr>
             <a:r>
@@ -2395,14 +2155,14 @@
           </a:bodyPr>
           <a:lstStyle/>
           <a:p>
-            <a:pPr algn="l" indent="0" marL="0">
+            <a:pPr marL="0" indent="0" algn="l">
               <a:lnSpc>
                 <a:spcPct val="104000"/>
               </a:lnSpc>
               <a:buNone/>
             </a:pPr>
             <a:r>
-              <a:rPr lang="en-US" sz="5400" b="1" spc="-108" kern="0" dirty="0">
+              <a:rPr lang="en-US" sz="5400" b="1" kern="0" spc="-108" dirty="0">
                 <a:solidFill>
                   <a:srgbClr val="0E1726"/>
                 </a:solidFill>
@@ -2439,7 +2199,7 @@
           </a:bodyPr>
           <a:lstStyle/>
           <a:p>
-            <a:pPr algn="l" indent="0" marL="0">
+            <a:pPr marL="0" indent="0" algn="l">
               <a:buNone/>
             </a:pPr>
             <a:r>
@@ -2476,6 +2236,13 @@
           </a:solidFill>
           <a:ln/>
         </p:spPr>
+        <p:txBody>
+          <a:bodyPr/>
+          <a:lstStyle/>
+          <a:p>
+            <a:endParaRPr lang="en-GB"/>
+          </a:p>
+        </p:txBody>
       </p:sp>
       <p:sp>
         <p:nvSpPr>
@@ -2500,7 +2267,7 @@
           </a:bodyPr>
           <a:lstStyle/>
           <a:p>
-            <a:pPr algn="l" indent="0" marL="0">
+            <a:pPr marL="0" indent="0" algn="l">
               <a:buNone/>
             </a:pPr>
             <a:r>
@@ -2537,6 +2304,13 @@
           </a:solidFill>
           <a:ln/>
         </p:spPr>
+        <p:txBody>
+          <a:bodyPr/>
+          <a:lstStyle/>
+          <a:p>
+            <a:endParaRPr lang="en-GB"/>
+          </a:p>
+        </p:txBody>
       </p:sp>
       <p:sp>
         <p:nvSpPr>
@@ -2561,7 +2335,7 @@
           </a:bodyPr>
           <a:lstStyle/>
           <a:p>
-            <a:pPr algn="l" indent="0" marL="0">
+            <a:pPr marL="0" indent="0" algn="l">
               <a:buNone/>
             </a:pPr>
             <a:r>
@@ -2598,6 +2372,13 @@
           </a:solidFill>
           <a:ln/>
         </p:spPr>
+        <p:txBody>
+          <a:bodyPr/>
+          <a:lstStyle/>
+          <a:p>
+            <a:endParaRPr lang="en-GB"/>
+          </a:p>
+        </p:txBody>
       </p:sp>
       <p:sp>
         <p:nvSpPr>
@@ -2622,7 +2403,7 @@
           </a:bodyPr>
           <a:lstStyle/>
           <a:p>
-            <a:pPr algn="l" indent="0" marL="0">
+            <a:pPr marL="0" indent="0" algn="l">
               <a:buNone/>
             </a:pPr>
             <a:r>
@@ -2659,6 +2440,13 @@
           </a:solidFill>
           <a:ln/>
         </p:spPr>
+        <p:txBody>
+          <a:bodyPr/>
+          <a:lstStyle/>
+          <a:p>
+            <a:endParaRPr lang="en-GB"/>
+          </a:p>
+        </p:txBody>
       </p:sp>
       <p:sp>
         <p:nvSpPr>
@@ -2683,7 +2471,7 @@
           </a:bodyPr>
           <a:lstStyle/>
           <a:p>
-            <a:pPr algn="l" indent="0" marL="0">
+            <a:pPr marL="0" indent="0" algn="l">
               <a:buNone/>
             </a:pPr>
             <a:r>
@@ -2720,6 +2508,13 @@
           </a:solidFill>
           <a:ln/>
         </p:spPr>
+        <p:txBody>
+          <a:bodyPr/>
+          <a:lstStyle/>
+          <a:p>
+            <a:endParaRPr lang="en-GB"/>
+          </a:p>
+        </p:txBody>
       </p:sp>
       <p:sp>
         <p:nvSpPr>
@@ -2740,6 +2535,13 @@
           </a:solidFill>
           <a:ln/>
         </p:spPr>
+        <p:txBody>
+          <a:bodyPr/>
+          <a:lstStyle/>
+          <a:p>
+            <a:endParaRPr lang="en-GB"/>
+          </a:p>
+        </p:txBody>
       </p:sp>
       <p:sp>
         <p:nvSpPr>
@@ -2764,7 +2566,7 @@
           </a:bodyPr>
           <a:lstStyle/>
           <a:p>
-            <a:pPr algn="ctr" indent="0" marL="0">
+            <a:pPr marL="0" indent="0" algn="ctr">
               <a:buNone/>
             </a:pPr>
             <a:r>
@@ -2805,7 +2607,7 @@
           </a:bodyPr>
           <a:lstStyle/>
           <a:p>
-            <a:pPr algn="ctr" indent="0" marL="0">
+            <a:pPr marL="0" indent="0" algn="ctr">
               <a:buNone/>
             </a:pPr>
             <a:r>
@@ -2846,7 +2648,7 @@
           </a:bodyPr>
           <a:lstStyle/>
           <a:p>
-            <a:pPr algn="ctr" indent="0" marL="0">
+            <a:pPr marL="0" indent="0" algn="ctr">
               <a:buNone/>
             </a:pPr>
             <a:r>
@@ -2887,7 +2689,7 @@
           </a:bodyPr>
           <a:lstStyle/>
           <a:p>
-            <a:pPr algn="ctr" indent="0" marL="0">
+            <a:pPr marL="0" indent="0" algn="ctr">
               <a:buNone/>
             </a:pPr>
             <a:r>
@@ -2928,7 +2730,7 @@
           </a:bodyPr>
           <a:lstStyle/>
           <a:p>
-            <a:pPr algn="ctr" indent="0" marL="0">
+            <a:pPr marL="0" indent="0" algn="ctr">
               <a:buNone/>
             </a:pPr>
             <a:r>
@@ -2965,6 +2767,13 @@
           </a:solidFill>
           <a:ln/>
         </p:spPr>
+        <p:txBody>
+          <a:bodyPr/>
+          <a:lstStyle/>
+          <a:p>
+            <a:endParaRPr lang="en-GB"/>
+          </a:p>
+        </p:txBody>
       </p:sp>
       <p:sp>
         <p:nvSpPr>
@@ -2989,14 +2798,14 @@
           </a:bodyPr>
           <a:lstStyle/>
           <a:p>
-            <a:pPr algn="l" indent="0" marL="0">
+            <a:pPr marL="0" indent="0" algn="l">
               <a:lnSpc>
                 <a:spcPct val="90000"/>
               </a:lnSpc>
               <a:buNone/>
             </a:pPr>
             <a:r>
-              <a:rPr lang="en-US" sz="9750" b="1" spc="-292" kern="0" dirty="0">
+              <a:rPr lang="en-US" sz="9750" b="1" kern="0" spc="-292" dirty="0">
                 <a:solidFill>
                   <a:srgbClr val="0E1726"/>
                 </a:solidFill>
@@ -3033,7 +2842,7 @@
           </a:bodyPr>
           <a:lstStyle/>
           <a:p>
-            <a:pPr algn="l" indent="0" marL="0">
+            <a:pPr marL="0" indent="0" algn="l">
               <a:lnSpc>
                 <a:spcPct val="145000"/>
               </a:lnSpc>
@@ -3050,12 +2859,6 @@
               </a:rPr>
               <a:t>The youngest cohort converts at </a:t>
             </a:r>
-            <a:pPr algn="l" indent="0" marL="0">
-              <a:lnSpc>
-                <a:spcPct val="145000"/>
-              </a:lnSpc>
-              <a:buNone/>
-            </a:pPr>
             <a:r>
               <a:rPr lang="en-US" sz="2250" b="1" dirty="0">
                 <a:solidFill>
@@ -3067,12 +2870,6 @@
               </a:rPr>
               <a:t>32.6% </a:t>
             </a:r>
-            <a:pPr algn="l" indent="0" marL="0">
-              <a:lnSpc>
-                <a:spcPct val="145000"/>
-              </a:lnSpc>
-              <a:buNone/>
-            </a:pPr>
             <a:r>
               <a:rPr lang="en-US" sz="2250" dirty="0">
                 <a:solidFill>
@@ -3084,12 +2881,6 @@
               </a:rPr>
               <a:t>— double the largest segment's </a:t>
             </a:r>
-            <a:pPr algn="l" indent="0" marL="0">
-              <a:lnSpc>
-                <a:spcPct val="145000"/>
-              </a:lnSpc>
-              <a:buNone/>
-            </a:pPr>
             <a:r>
               <a:rPr lang="en-US" sz="2250" b="1" dirty="0">
                 <a:solidFill>
@@ -3101,12 +2892,6 @@
               </a:rPr>
               <a:t>16.4% </a:t>
             </a:r>
-            <a:pPr algn="l" indent="0" marL="0">
-              <a:lnSpc>
-                <a:spcPct val="145000"/>
-              </a:lnSpc>
-              <a:buNone/>
-            </a:pPr>
             <a:r>
               <a:rPr lang="en-US" sz="2250" dirty="0">
                 <a:solidFill>
@@ -3138,6 +2923,7 @@
         <a:solidFill>
           <a:srgbClr val="F8FAFC"/>
         </a:solidFill>
+        <a:effectLst/>
       </p:bgPr>
     </p:bg>
     <p:spTree>
@@ -3177,11 +2963,11 @@
           </a:bodyPr>
           <a:lstStyle/>
           <a:p>
-            <a:pPr algn="l" indent="0" marL="0">
-              <a:buNone/>
-            </a:pPr>
-            <a:r>
-              <a:rPr lang="en-US" sz="1800" b="1" spc="324" kern="0" dirty="0">
+            <a:pPr marL="0" indent="0" algn="l">
+              <a:buNone/>
+            </a:pPr>
+            <a:r>
+              <a:rPr lang="en-US" sz="1800" b="1" kern="0" spc="324" dirty="0">
                 <a:solidFill>
                   <a:srgbClr val="2563EB"/>
                 </a:solidFill>
@@ -3218,7 +3004,7 @@
           </a:bodyPr>
           <a:lstStyle/>
           <a:p>
-            <a:pPr algn="l" indent="0" marL="0">
+            <a:pPr marL="0" indent="0" algn="l">
               <a:buNone/>
             </a:pPr>
             <a:r>
@@ -3259,14 +3045,14 @@
           </a:bodyPr>
           <a:lstStyle/>
           <a:p>
-            <a:pPr algn="l" indent="0" marL="0">
+            <a:pPr marL="0" indent="0" algn="l">
               <a:lnSpc>
                 <a:spcPct val="104000"/>
               </a:lnSpc>
               <a:buNone/>
             </a:pPr>
             <a:r>
-              <a:rPr lang="en-US" sz="5400" b="1" spc="-108" kern="0" dirty="0">
+              <a:rPr lang="en-US" sz="5400" b="1" kern="0" spc="-108" dirty="0">
                 <a:solidFill>
                   <a:srgbClr val="0E1726"/>
                 </a:solidFill>
@@ -3303,7 +3089,7 @@
           </a:bodyPr>
           <a:lstStyle/>
           <a:p>
-            <a:pPr algn="l" indent="0" marL="0">
+            <a:pPr marL="0" indent="0" algn="l">
               <a:buNone/>
             </a:pPr>
             <a:r>
@@ -3340,6 +3126,13 @@
           </a:solidFill>
           <a:ln/>
         </p:spPr>
+        <p:txBody>
+          <a:bodyPr/>
+          <a:lstStyle/>
+          <a:p>
+            <a:endParaRPr lang="en-GB"/>
+          </a:p>
+        </p:txBody>
       </p:sp>
       <p:sp>
         <p:nvSpPr>
@@ -3364,7 +3157,7 @@
           </a:bodyPr>
           <a:lstStyle/>
           <a:p>
-            <a:pPr algn="l" indent="0" marL="0">
+            <a:pPr marL="0" indent="0" algn="l">
               <a:buNone/>
             </a:pPr>
             <a:r>
@@ -3401,6 +3194,13 @@
           </a:solidFill>
           <a:ln/>
         </p:spPr>
+        <p:txBody>
+          <a:bodyPr/>
+          <a:lstStyle/>
+          <a:p>
+            <a:endParaRPr lang="en-GB"/>
+          </a:p>
+        </p:txBody>
       </p:sp>
       <p:sp>
         <p:nvSpPr>
@@ -3425,7 +3225,7 @@
           </a:bodyPr>
           <a:lstStyle/>
           <a:p>
-            <a:pPr algn="l" indent="0" marL="0">
+            <a:pPr marL="0" indent="0" algn="l">
               <a:buNone/>
             </a:pPr>
             <a:r>
@@ -3462,6 +3262,13 @@
           </a:solidFill>
           <a:ln/>
         </p:spPr>
+        <p:txBody>
+          <a:bodyPr/>
+          <a:lstStyle/>
+          <a:p>
+            <a:endParaRPr lang="en-GB"/>
+          </a:p>
+        </p:txBody>
       </p:sp>
       <p:sp>
         <p:nvSpPr>
@@ -3486,7 +3293,7 @@
           </a:bodyPr>
           <a:lstStyle/>
           <a:p>
-            <a:pPr algn="l" indent="0" marL="0">
+            <a:pPr marL="0" indent="0" algn="l">
               <a:buNone/>
             </a:pPr>
             <a:r>
@@ -3523,6 +3330,13 @@
           </a:solidFill>
           <a:ln/>
         </p:spPr>
+        <p:txBody>
+          <a:bodyPr/>
+          <a:lstStyle/>
+          <a:p>
+            <a:endParaRPr lang="en-GB"/>
+          </a:p>
+        </p:txBody>
       </p:sp>
       <p:sp>
         <p:nvSpPr>
@@ -3547,7 +3361,7 @@
           </a:bodyPr>
           <a:lstStyle/>
           <a:p>
-            <a:pPr algn="l" indent="0" marL="0">
+            <a:pPr marL="0" indent="0" algn="l">
               <a:buNone/>
             </a:pPr>
             <a:r>
@@ -3584,6 +3398,13 @@
           </a:solidFill>
           <a:ln/>
         </p:spPr>
+        <p:txBody>
+          <a:bodyPr/>
+          <a:lstStyle/>
+          <a:p>
+            <a:endParaRPr lang="en-GB"/>
+          </a:p>
+        </p:txBody>
       </p:sp>
       <p:sp>
         <p:nvSpPr>
@@ -3608,7 +3429,7 @@
           </a:bodyPr>
           <a:lstStyle/>
           <a:p>
-            <a:pPr algn="l" indent="0" marL="0">
+            <a:pPr marL="0" indent="0" algn="l">
               <a:buNone/>
             </a:pPr>
             <a:r>
@@ -3645,6 +3466,13 @@
           </a:solidFill>
           <a:ln/>
         </p:spPr>
+        <p:txBody>
+          <a:bodyPr/>
+          <a:lstStyle/>
+          <a:p>
+            <a:endParaRPr lang="en-GB"/>
+          </a:p>
+        </p:txBody>
       </p:sp>
       <p:sp>
         <p:nvSpPr>
@@ -3669,7 +3497,7 @@
           </a:bodyPr>
           <a:lstStyle/>
           <a:p>
-            <a:pPr algn="ctr" indent="0" marL="0">
+            <a:pPr marL="0" indent="0" algn="ctr">
               <a:buNone/>
             </a:pPr>
             <a:r>
@@ -3710,7 +3538,7 @@
           </a:bodyPr>
           <a:lstStyle/>
           <a:p>
-            <a:pPr algn="ctr" indent="0" marL="0">
+            <a:pPr marL="0" indent="0" algn="ctr">
               <a:buNone/>
             </a:pPr>
             <a:r>
@@ -3751,7 +3579,7 @@
           </a:bodyPr>
           <a:lstStyle/>
           <a:p>
-            <a:pPr algn="ctr" indent="0" marL="0">
+            <a:pPr marL="0" indent="0" algn="ctr">
               <a:buNone/>
             </a:pPr>
             <a:r>
@@ -3788,6 +3616,13 @@
           </a:solidFill>
           <a:ln/>
         </p:spPr>
+        <p:txBody>
+          <a:bodyPr/>
+          <a:lstStyle/>
+          <a:p>
+            <a:endParaRPr lang="en-GB"/>
+          </a:p>
+        </p:txBody>
       </p:sp>
       <p:sp>
         <p:nvSpPr>
@@ -3812,7 +3647,7 @@
           </a:bodyPr>
           <a:lstStyle/>
           <a:p>
-            <a:pPr algn="l" indent="0" marL="0">
+            <a:pPr marL="0" indent="0" algn="l">
               <a:buNone/>
             </a:pPr>
             <a:r>
@@ -3849,6 +3684,13 @@
           </a:solidFill>
           <a:ln/>
         </p:spPr>
+        <p:txBody>
+          <a:bodyPr/>
+          <a:lstStyle/>
+          <a:p>
+            <a:endParaRPr lang="en-GB"/>
+          </a:p>
+        </p:txBody>
       </p:sp>
       <p:sp>
         <p:nvSpPr>
@@ -3873,7 +3715,7 @@
           </a:bodyPr>
           <a:lstStyle/>
           <a:p>
-            <a:pPr algn="l" indent="0" marL="0">
+            <a:pPr marL="0" indent="0" algn="l">
               <a:buNone/>
             </a:pPr>
             <a:r>
@@ -3910,6 +3752,13 @@
           </a:solidFill>
           <a:ln/>
         </p:spPr>
+        <p:txBody>
+          <a:bodyPr/>
+          <a:lstStyle/>
+          <a:p>
+            <a:endParaRPr lang="en-GB"/>
+          </a:p>
+        </p:txBody>
       </p:sp>
       <p:sp>
         <p:nvSpPr>
@@ -3934,7 +3783,7 @@
           </a:bodyPr>
           <a:lstStyle/>
           <a:p>
-            <a:pPr algn="l" indent="0" marL="0">
+            <a:pPr marL="0" indent="0" algn="l">
               <a:lnSpc>
                 <a:spcPct val="145000"/>
               </a:lnSpc>
@@ -3951,12 +3800,6 @@
               </a:rPr>
               <a:t>Browsing takes time — the first thing that vanishes when children arrive. Price sensitivity replaces it. So a catalog mailed to a family is </a:t>
             </a:r>
-            <a:pPr algn="l" indent="0" marL="0">
-              <a:lnSpc>
-                <a:spcPct val="145000"/>
-              </a:lnSpc>
-              <a:buNone/>
-            </a:pPr>
             <a:r>
               <a:rPr lang="en-US" sz="2250" b="1" dirty="0">
                 <a:solidFill>
@@ -3968,12 +3811,6 @@
               </a:rPr>
               <a:t>mostly wasted print </a:t>
             </a:r>
-            <a:pPr algn="l" indent="0" marL="0">
-              <a:lnSpc>
-                <a:spcPct val="145000"/>
-              </a:lnSpc>
-              <a:buNone/>
-            </a:pPr>
             <a:r>
               <a:rPr lang="en-US" sz="2250" dirty="0">
                 <a:solidFill>
@@ -4012,7 +3849,7 @@
           </a:bodyPr>
           <a:lstStyle/>
           <a:p>
-            <a:pPr algn="l" indent="0" marL="0">
+            <a:pPr marL="0" indent="0" algn="l">
               <a:lnSpc>
                 <a:spcPct val="140000"/>
               </a:lnSpc>
@@ -4029,12 +3866,6 @@
               </a:rPr>
               <a:t>The </a:t>
             </a:r>
-            <a:pPr algn="l" indent="0" marL="0">
-              <a:lnSpc>
-                <a:spcPct val="140000"/>
-              </a:lnSpc>
-              <a:buNone/>
-            </a:pPr>
             <a:r>
               <a:rPr lang="en-US" sz="1800" dirty="0">
                 <a:solidFill>
@@ -4046,12 +3877,6 @@
               </a:rPr>
               <a:t>has-children </a:t>
             </a:r>
-            <a:pPr algn="l" indent="0" marL="0">
-              <a:lnSpc>
-                <a:spcPct val="140000"/>
-              </a:lnSpc>
-              <a:buNone/>
-            </a:pPr>
             <a:r>
               <a:rPr lang="en-US" sz="1950" dirty="0">
                 <a:solidFill>
@@ -4083,6 +3908,7 @@
         <a:solidFill>
           <a:srgbClr val="F8FAFC"/>
         </a:solidFill>
+        <a:effectLst/>
       </p:bgPr>
     </p:bg>
     <p:spTree>
@@ -4122,11 +3948,11 @@
           </a:bodyPr>
           <a:lstStyle/>
           <a:p>
-            <a:pPr algn="l" indent="0" marL="0">
-              <a:buNone/>
-            </a:pPr>
-            <a:r>
-              <a:rPr lang="en-US" sz="1800" b="1" spc="324" kern="0" dirty="0">
+            <a:pPr marL="0" indent="0" algn="l">
+              <a:buNone/>
+            </a:pPr>
+            <a:r>
+              <a:rPr lang="en-US" sz="1800" b="1" kern="0" spc="324" dirty="0">
                 <a:solidFill>
                   <a:srgbClr val="2563EB"/>
                 </a:solidFill>
@@ -4163,7 +3989,7 @@
           </a:bodyPr>
           <a:lstStyle/>
           <a:p>
-            <a:pPr algn="l" indent="0" marL="0">
+            <a:pPr marL="0" indent="0" algn="l">
               <a:buNone/>
             </a:pPr>
             <a:r>
@@ -4204,14 +4030,14 @@
           </a:bodyPr>
           <a:lstStyle/>
           <a:p>
-            <a:pPr algn="l" indent="0" marL="0">
+            <a:pPr marL="0" indent="0" algn="l">
               <a:lnSpc>
                 <a:spcPct val="104000"/>
               </a:lnSpc>
               <a:buNone/>
             </a:pPr>
             <a:r>
-              <a:rPr lang="en-US" sz="5400" b="1" spc="-108" kern="0" dirty="0">
+              <a:rPr lang="en-US" sz="5400" b="1" kern="0" spc="-108" dirty="0">
                 <a:solidFill>
                   <a:srgbClr val="0E1726"/>
                 </a:solidFill>
@@ -4248,7 +4074,7 @@
           </a:bodyPr>
           <a:lstStyle/>
           <a:p>
-            <a:pPr algn="l" indent="0" marL="0">
+            <a:pPr marL="0" indent="0" algn="l">
               <a:buNone/>
             </a:pPr>
             <a:r>
@@ -4285,6 +4111,13 @@
           </a:solidFill>
           <a:ln/>
         </p:spPr>
+        <p:txBody>
+          <a:bodyPr/>
+          <a:lstStyle/>
+          <a:p>
+            <a:endParaRPr lang="en-GB"/>
+          </a:p>
+        </p:txBody>
       </p:sp>
       <p:sp>
         <p:nvSpPr>
@@ -4309,7 +4142,7 @@
           </a:bodyPr>
           <a:lstStyle/>
           <a:p>
-            <a:pPr algn="l" indent="0" marL="0">
+            <a:pPr marL="0" indent="0" algn="l">
               <a:buNone/>
             </a:pPr>
             <a:r>
@@ -4346,6 +4179,13 @@
           </a:solidFill>
           <a:ln/>
         </p:spPr>
+        <p:txBody>
+          <a:bodyPr/>
+          <a:lstStyle/>
+          <a:p>
+            <a:endParaRPr lang="en-GB"/>
+          </a:p>
+        </p:txBody>
       </p:sp>
       <p:sp>
         <p:nvSpPr>
@@ -4366,6 +4206,13 @@
           </a:solidFill>
           <a:ln/>
         </p:spPr>
+        <p:txBody>
+          <a:bodyPr/>
+          <a:lstStyle/>
+          <a:p>
+            <a:endParaRPr lang="en-GB"/>
+          </a:p>
+        </p:txBody>
       </p:sp>
       <p:sp>
         <p:nvSpPr>
@@ -4390,7 +4237,7 @@
           </a:bodyPr>
           <a:lstStyle/>
           <a:p>
-            <a:pPr algn="l" indent="0" marL="0">
+            <a:pPr marL="0" indent="0" algn="l">
               <a:buNone/>
             </a:pPr>
             <a:r>
@@ -4427,6 +4274,13 @@
           </a:solidFill>
           <a:ln/>
         </p:spPr>
+        <p:txBody>
+          <a:bodyPr/>
+          <a:lstStyle/>
+          <a:p>
+            <a:endParaRPr lang="en-GB"/>
+          </a:p>
+        </p:txBody>
       </p:sp>
       <p:sp>
         <p:nvSpPr>
@@ -4451,7 +4305,7 @@
           </a:bodyPr>
           <a:lstStyle/>
           <a:p>
-            <a:pPr algn="l" indent="0" marL="0">
+            <a:pPr marL="0" indent="0" algn="l">
               <a:buNone/>
             </a:pPr>
             <a:r>
@@ -4488,6 +4342,13 @@
           </a:solidFill>
           <a:ln/>
         </p:spPr>
+        <p:txBody>
+          <a:bodyPr/>
+          <a:lstStyle/>
+          <a:p>
+            <a:endParaRPr lang="en-GB"/>
+          </a:p>
+        </p:txBody>
       </p:sp>
       <p:sp>
         <p:nvSpPr>
@@ -4512,7 +4373,7 @@
           </a:bodyPr>
           <a:lstStyle/>
           <a:p>
-            <a:pPr algn="l" indent="0" marL="0">
+            <a:pPr marL="0" indent="0" algn="l">
               <a:buNone/>
             </a:pPr>
             <a:r>
@@ -4549,6 +4410,13 @@
           </a:solidFill>
           <a:ln/>
         </p:spPr>
+        <p:txBody>
+          <a:bodyPr/>
+          <a:lstStyle/>
+          <a:p>
+            <a:endParaRPr lang="en-GB"/>
+          </a:p>
+        </p:txBody>
       </p:sp>
       <p:sp>
         <p:nvSpPr>
@@ -4573,7 +4441,7 @@
           </a:bodyPr>
           <a:lstStyle/>
           <a:p>
-            <a:pPr algn="l" indent="0" marL="0">
+            <a:pPr marL="0" indent="0" algn="l">
               <a:buNone/>
             </a:pPr>
             <a:r>
@@ -4610,6 +4478,13 @@
           </a:solidFill>
           <a:ln/>
         </p:spPr>
+        <p:txBody>
+          <a:bodyPr/>
+          <a:lstStyle/>
+          <a:p>
+            <a:endParaRPr lang="en-GB"/>
+          </a:p>
+        </p:txBody>
       </p:sp>
       <p:sp>
         <p:nvSpPr>
@@ -4634,7 +4509,7 @@
           </a:bodyPr>
           <a:lstStyle/>
           <a:p>
-            <a:pPr algn="l" indent="0" marL="0">
+            <a:pPr marL="0" indent="0" algn="l">
               <a:buNone/>
             </a:pPr>
             <a:r>
@@ -4671,6 +4546,13 @@
           </a:solidFill>
           <a:ln/>
         </p:spPr>
+        <p:txBody>
+          <a:bodyPr/>
+          <a:lstStyle/>
+          <a:p>
+            <a:endParaRPr lang="en-GB"/>
+          </a:p>
+        </p:txBody>
       </p:sp>
       <p:sp>
         <p:nvSpPr>
@@ -4695,7 +4577,7 @@
           </a:bodyPr>
           <a:lstStyle/>
           <a:p>
-            <a:pPr algn="l" indent="0" marL="0">
+            <a:pPr marL="0" indent="0" algn="l">
               <a:buNone/>
             </a:pPr>
             <a:r>
@@ -4732,6 +4614,13 @@
           </a:solidFill>
           <a:ln/>
         </p:spPr>
+        <p:txBody>
+          <a:bodyPr/>
+          <a:lstStyle/>
+          <a:p>
+            <a:endParaRPr lang="en-GB"/>
+          </a:p>
+        </p:txBody>
       </p:sp>
       <p:sp>
         <p:nvSpPr>
@@ -4756,7 +4645,7 @@
           </a:bodyPr>
           <a:lstStyle/>
           <a:p>
-            <a:pPr algn="l" indent="0" marL="0">
+            <a:pPr marL="0" indent="0" algn="l">
               <a:buNone/>
             </a:pPr>
             <a:r>
@@ -4793,6 +4682,13 @@
           </a:solidFill>
           <a:ln/>
         </p:spPr>
+        <p:txBody>
+          <a:bodyPr/>
+          <a:lstStyle/>
+          <a:p>
+            <a:endParaRPr lang="en-GB"/>
+          </a:p>
+        </p:txBody>
       </p:sp>
       <p:sp>
         <p:nvSpPr>
@@ -4817,7 +4713,7 @@
           </a:bodyPr>
           <a:lstStyle/>
           <a:p>
-            <a:pPr algn="l" indent="0" marL="0">
+            <a:pPr marL="0" indent="0" algn="l">
               <a:buNone/>
             </a:pPr>
             <a:r>
@@ -4854,6 +4750,13 @@
           </a:solidFill>
           <a:ln/>
         </p:spPr>
+        <p:txBody>
+          <a:bodyPr/>
+          <a:lstStyle/>
+          <a:p>
+            <a:endParaRPr lang="en-GB"/>
+          </a:p>
+        </p:txBody>
       </p:sp>
       <p:sp>
         <p:nvSpPr>
@@ -4878,7 +4781,7 @@
           </a:bodyPr>
           <a:lstStyle/>
           <a:p>
-            <a:pPr algn="ctr" indent="0" marL="0">
+            <a:pPr marL="0" indent="0" algn="ctr">
               <a:buNone/>
             </a:pPr>
             <a:r>
@@ -4919,7 +4822,7 @@
           </a:bodyPr>
           <a:lstStyle/>
           <a:p>
-            <a:pPr algn="ctr" indent="0" marL="0">
+            <a:pPr marL="0" indent="0" algn="ctr">
               <a:buNone/>
             </a:pPr>
             <a:r>
@@ -4960,7 +4863,7 @@
           </a:bodyPr>
           <a:lstStyle/>
           <a:p>
-            <a:pPr algn="ctr" indent="0" marL="0">
+            <a:pPr marL="0" indent="0" algn="ctr">
               <a:buNone/>
             </a:pPr>
             <a:r>
@@ -5001,7 +4904,7 @@
           </a:bodyPr>
           <a:lstStyle/>
           <a:p>
-            <a:pPr algn="ctr" indent="0" marL="0">
+            <a:pPr marL="0" indent="0" algn="ctr">
               <a:buNone/>
             </a:pPr>
             <a:r>
@@ -5042,7 +4945,7 @@
           </a:bodyPr>
           <a:lstStyle/>
           <a:p>
-            <a:pPr algn="ctr" indent="0" marL="0">
+            <a:pPr marL="0" indent="0" algn="ctr">
               <a:buNone/>
             </a:pPr>
             <a:r>
@@ -5079,6 +4982,13 @@
           </a:solidFill>
           <a:ln/>
         </p:spPr>
+        <p:txBody>
+          <a:bodyPr/>
+          <a:lstStyle/>
+          <a:p>
+            <a:endParaRPr lang="en-GB"/>
+          </a:p>
+        </p:txBody>
       </p:sp>
       <p:sp>
         <p:nvSpPr>
@@ -5103,7 +5013,7 @@
           </a:bodyPr>
           <a:lstStyle/>
           <a:p>
-            <a:pPr algn="l" indent="0" marL="0">
+            <a:pPr marL="0" indent="0" algn="l">
               <a:buNone/>
             </a:pPr>
             <a:r>
@@ -5140,6 +5050,13 @@
           </a:solidFill>
           <a:ln/>
         </p:spPr>
+        <p:txBody>
+          <a:bodyPr/>
+          <a:lstStyle/>
+          <a:p>
+            <a:endParaRPr lang="en-GB"/>
+          </a:p>
+        </p:txBody>
       </p:sp>
       <p:sp>
         <p:nvSpPr>
@@ -5164,7 +5081,7 @@
           </a:bodyPr>
           <a:lstStyle/>
           <a:p>
-            <a:pPr algn="l" indent="0" marL="0">
+            <a:pPr marL="0" indent="0" algn="l">
               <a:buNone/>
             </a:pPr>
             <a:r>
@@ -5201,6 +5118,13 @@
           </a:solidFill>
           <a:ln/>
         </p:spPr>
+        <p:txBody>
+          <a:bodyPr/>
+          <a:lstStyle/>
+          <a:p>
+            <a:endParaRPr lang="en-GB"/>
+          </a:p>
+        </p:txBody>
       </p:sp>
       <p:sp>
         <p:nvSpPr>
@@ -5221,6 +5145,13 @@
           </a:solidFill>
           <a:ln/>
         </p:spPr>
+        <p:txBody>
+          <a:bodyPr/>
+          <a:lstStyle/>
+          <a:p>
+            <a:endParaRPr lang="en-GB"/>
+          </a:p>
+        </p:txBody>
       </p:sp>
       <p:sp>
         <p:nvSpPr>
@@ -5245,7 +5176,7 @@
           </a:bodyPr>
           <a:lstStyle/>
           <a:p>
-            <a:pPr algn="l" indent="0" marL="0">
+            <a:pPr marL="0" indent="0" algn="l">
               <a:buNone/>
             </a:pPr>
             <a:r>
@@ -5282,6 +5213,13 @@
           </a:solidFill>
           <a:ln/>
         </p:spPr>
+        <p:txBody>
+          <a:bodyPr/>
+          <a:lstStyle/>
+          <a:p>
+            <a:endParaRPr lang="en-GB"/>
+          </a:p>
+        </p:txBody>
       </p:sp>
       <p:sp>
         <p:nvSpPr>
@@ -5306,14 +5244,14 @@
           </a:bodyPr>
           <a:lstStyle/>
           <a:p>
-            <a:pPr algn="l" indent="0" marL="0">
+            <a:pPr marL="0" indent="0" algn="l">
               <a:lnSpc>
                 <a:spcPct val="90000"/>
               </a:lnSpc>
               <a:buNone/>
             </a:pPr>
             <a:r>
-              <a:rPr lang="en-US" sz="8250" b="1" spc="-247" kern="0" dirty="0">
+              <a:rPr lang="en-US" sz="8250" b="1" kern="0" spc="-247" dirty="0">
                 <a:solidFill>
                   <a:srgbClr val="0E1726"/>
                 </a:solidFill>
@@ -5350,7 +5288,7 @@
           </a:bodyPr>
           <a:lstStyle/>
           <a:p>
-            <a:pPr algn="l" indent="0" marL="0">
+            <a:pPr marL="0" indent="0" algn="l">
               <a:lnSpc>
                 <a:spcPct val="145000"/>
               </a:lnSpc>
@@ -5367,12 +5305,6 @@
               </a:rPr>
               <a:t>Wine scales nearly sixtyfold across income — a clean income proxy. But below $30k, </a:t>
             </a:r>
-            <a:pPr algn="l" indent="0" marL="0">
-              <a:lnSpc>
-                <a:spcPct val="145000"/>
-              </a:lnSpc>
-              <a:buNone/>
-            </a:pPr>
             <a:r>
               <a:rPr lang="en-US" sz="2250" b="1" dirty="0">
                 <a:solidFill>
@@ -5384,12 +5316,6 @@
               </a:rPr>
               <a:t>meat outspends wine</a:t>
             </a:r>
-            <a:pPr algn="l" indent="0" marL="0">
-              <a:lnSpc>
-                <a:spcPct val="145000"/>
-              </a:lnSpc>
-              <a:buNone/>
-            </a:pPr>
             <a:r>
               <a:rPr lang="en-US" sz="2250" dirty="0">
                 <a:solidFill>
@@ -5401,12 +5327,6 @@
               </a:rPr>
               <a:t>. Those </a:t>
             </a:r>
-            <a:pPr algn="l" indent="0" marL="0">
-              <a:lnSpc>
-                <a:spcPct val="145000"/>
-              </a:lnSpc>
-              <a:buNone/>
-            </a:pPr>
             <a:r>
               <a:rPr lang="en-US" sz="2250" b="1" dirty="0">
                 <a:solidFill>
@@ -5418,12 +5338,6 @@
               </a:rPr>
               <a:t>370 customers (≈17%) </a:t>
             </a:r>
-            <a:pPr algn="l" indent="0" marL="0">
-              <a:lnSpc>
-                <a:spcPct val="145000"/>
-              </a:lnSpc>
-              <a:buNone/>
-            </a:pPr>
             <a:r>
               <a:rPr lang="en-US" sz="2250" dirty="0">
                 <a:solidFill>
@@ -5455,6 +5369,7 @@
         <a:solidFill>
           <a:srgbClr val="0E1726"/>
         </a:solidFill>
+        <a:effectLst/>
       </p:bgPr>
     </p:bg>
     <p:spTree>
@@ -5494,11 +5409,11 @@
           </a:bodyPr>
           <a:lstStyle/>
           <a:p>
-            <a:pPr algn="l" indent="0" marL="0">
-              <a:buNone/>
-            </a:pPr>
-            <a:r>
-              <a:rPr lang="en-US" sz="1800" b="1" spc="324" kern="0" dirty="0">
+            <a:pPr marL="0" indent="0" algn="l">
+              <a:buNone/>
+            </a:pPr>
+            <a:r>
+              <a:rPr lang="en-US" sz="1800" b="1" kern="0" spc="324" dirty="0">
                 <a:solidFill>
                   <a:srgbClr val="93B4FB"/>
                 </a:solidFill>
@@ -5535,14 +5450,14 @@
           </a:bodyPr>
           <a:lstStyle/>
           <a:p>
-            <a:pPr algn="l" indent="0" marL="0">
+            <a:pPr marL="0" indent="0" algn="l">
               <a:lnSpc>
                 <a:spcPct val="106000"/>
               </a:lnSpc>
               <a:buNone/>
             </a:pPr>
             <a:r>
-              <a:rPr lang="en-US" sz="5250" b="1" spc="-105" kern="0" dirty="0">
+              <a:rPr lang="en-US" sz="5250" b="1" kern="0" spc="-105" dirty="0">
                 <a:solidFill>
                   <a:srgbClr val="FFFFFF"/>
                 </a:solidFill>
@@ -5575,6 +5490,13 @@
           </a:solidFill>
           <a:ln/>
         </p:spPr>
+        <p:txBody>
+          <a:bodyPr/>
+          <a:lstStyle/>
+          <a:p>
+            <a:endParaRPr lang="en-GB"/>
+          </a:p>
+        </p:txBody>
       </p:sp>
       <p:sp>
         <p:nvSpPr>
@@ -5595,6 +5517,13 @@
           </a:solidFill>
           <a:ln/>
         </p:spPr>
+        <p:txBody>
+          <a:bodyPr/>
+          <a:lstStyle/>
+          <a:p>
+            <a:endParaRPr lang="en-GB"/>
+          </a:p>
+        </p:txBody>
       </p:sp>
       <p:sp>
         <p:nvSpPr>
@@ -5619,7 +5548,7 @@
           </a:bodyPr>
           <a:lstStyle/>
           <a:p>
-            <a:pPr algn="l" indent="0" marL="0">
+            <a:pPr marL="0" indent="0" algn="l">
               <a:buNone/>
             </a:pPr>
             <a:r>
@@ -5660,14 +5589,14 @@
           </a:bodyPr>
           <a:lstStyle/>
           <a:p>
-            <a:pPr algn="l" indent="0" marL="0">
+            <a:pPr marL="0" indent="0" algn="l">
               <a:lnSpc>
                 <a:spcPct val="112000"/>
               </a:lnSpc>
               <a:buNone/>
             </a:pPr>
             <a:r>
-              <a:rPr lang="en-US" sz="2850" b="1" spc="-29" kern="0" dirty="0">
+              <a:rPr lang="en-US" sz="2850" b="1" kern="0" spc="-29" dirty="0">
                 <a:solidFill>
                   <a:srgbClr val="FFFFFF"/>
                 </a:solidFill>
@@ -5704,7 +5633,7 @@
           </a:bodyPr>
           <a:lstStyle/>
           <a:p>
-            <a:pPr algn="l" indent="0" marL="0">
+            <a:pPr marL="0" indent="0" algn="l">
               <a:lnSpc>
                 <a:spcPct val="142000"/>
               </a:lnSpc>
@@ -5744,6 +5673,13 @@
           </a:solidFill>
           <a:ln/>
         </p:spPr>
+        <p:txBody>
+          <a:bodyPr/>
+          <a:lstStyle/>
+          <a:p>
+            <a:endParaRPr lang="en-GB"/>
+          </a:p>
+        </p:txBody>
       </p:sp>
       <p:sp>
         <p:nvSpPr>
@@ -5764,6 +5700,13 @@
           </a:solidFill>
           <a:ln/>
         </p:spPr>
+        <p:txBody>
+          <a:bodyPr/>
+          <a:lstStyle/>
+          <a:p>
+            <a:endParaRPr lang="en-GB"/>
+          </a:p>
+        </p:txBody>
       </p:sp>
       <p:sp>
         <p:nvSpPr>
@@ -5788,7 +5731,7 @@
           </a:bodyPr>
           <a:lstStyle/>
           <a:p>
-            <a:pPr algn="l" indent="0" marL="0">
+            <a:pPr marL="0" indent="0" algn="l">
               <a:buNone/>
             </a:pPr>
             <a:r>
@@ -5829,14 +5772,14 @@
           </a:bodyPr>
           <a:lstStyle/>
           <a:p>
-            <a:pPr algn="l" indent="0" marL="0">
+            <a:pPr marL="0" indent="0" algn="l">
               <a:lnSpc>
                 <a:spcPct val="112000"/>
               </a:lnSpc>
               <a:buNone/>
             </a:pPr>
             <a:r>
-              <a:rPr lang="en-US" sz="2850" b="1" spc="-29" kern="0" dirty="0">
+              <a:rPr lang="en-US" sz="2850" b="1" kern="0" spc="-29" dirty="0">
                 <a:solidFill>
                   <a:srgbClr val="FFFFFF"/>
                 </a:solidFill>
@@ -5873,7 +5816,7 @@
           </a:bodyPr>
           <a:lstStyle/>
           <a:p>
-            <a:pPr algn="l" indent="0" marL="0">
+            <a:pPr marL="0" indent="0" algn="l">
               <a:lnSpc>
                 <a:spcPct val="142000"/>
               </a:lnSpc>
@@ -5913,6 +5856,13 @@
           </a:solidFill>
           <a:ln/>
         </p:spPr>
+        <p:txBody>
+          <a:bodyPr/>
+          <a:lstStyle/>
+          <a:p>
+            <a:endParaRPr lang="en-GB"/>
+          </a:p>
+        </p:txBody>
       </p:sp>
       <p:sp>
         <p:nvSpPr>
@@ -5933,6 +5883,13 @@
           </a:solidFill>
           <a:ln/>
         </p:spPr>
+        <p:txBody>
+          <a:bodyPr/>
+          <a:lstStyle/>
+          <a:p>
+            <a:endParaRPr lang="en-GB"/>
+          </a:p>
+        </p:txBody>
       </p:sp>
       <p:sp>
         <p:nvSpPr>
@@ -5957,7 +5914,7 @@
           </a:bodyPr>
           <a:lstStyle/>
           <a:p>
-            <a:pPr algn="l" indent="0" marL="0">
+            <a:pPr marL="0" indent="0" algn="l">
               <a:buNone/>
             </a:pPr>
             <a:r>
@@ -5998,14 +5955,14 @@
           </a:bodyPr>
           <a:lstStyle/>
           <a:p>
-            <a:pPr algn="l" indent="0" marL="0">
+            <a:pPr marL="0" indent="0" algn="l">
               <a:lnSpc>
                 <a:spcPct val="112000"/>
               </a:lnSpc>
               <a:buNone/>
             </a:pPr>
             <a:r>
-              <a:rPr lang="en-US" sz="2850" b="1" spc="-29" kern="0" dirty="0">
+              <a:rPr lang="en-US" sz="2850" b="1" kern="0" spc="-29" dirty="0">
                 <a:solidFill>
                   <a:srgbClr val="FFFFFF"/>
                 </a:solidFill>
@@ -6042,7 +5999,7 @@
           </a:bodyPr>
           <a:lstStyle/>
           <a:p>
-            <a:pPr algn="l" indent="0" marL="0">
+            <a:pPr marL="0" indent="0" algn="l">
               <a:lnSpc>
                 <a:spcPct val="142000"/>
               </a:lnSpc>
@@ -6079,6 +6036,7 @@
         <a:solidFill>
           <a:srgbClr val="F8FAFC"/>
         </a:solidFill>
+        <a:effectLst/>
       </p:bgPr>
     </p:bg>
     <p:spTree>
@@ -6118,11 +6076,11 @@
           </a:bodyPr>
           <a:lstStyle/>
           <a:p>
-            <a:pPr algn="l" indent="0" marL="0">
-              <a:buNone/>
-            </a:pPr>
-            <a:r>
-              <a:rPr lang="en-US" sz="1800" b="1" spc="324" kern="0" dirty="0">
+            <a:pPr marL="0" indent="0" algn="l">
+              <a:buNone/>
+            </a:pPr>
+            <a:r>
+              <a:rPr lang="en-US" sz="1800" b="1" kern="0" spc="324" dirty="0">
                 <a:solidFill>
                   <a:srgbClr val="2563EB"/>
                 </a:solidFill>
@@ -6159,14 +6117,14 @@
           </a:bodyPr>
           <a:lstStyle/>
           <a:p>
-            <a:pPr algn="l" indent="0" marL="0">
+            <a:pPr marL="0" indent="0" algn="l">
               <a:lnSpc>
                 <a:spcPct val="104000"/>
               </a:lnSpc>
               <a:buNone/>
             </a:pPr>
             <a:r>
-              <a:rPr lang="en-US" sz="6900" b="1" spc="-172" kern="0" dirty="0">
+              <a:rPr lang="en-US" sz="6900" b="1" kern="0" spc="-172" dirty="0">
                 <a:solidFill>
                   <a:srgbClr val="0E1726"/>
                 </a:solidFill>
@@ -6203,7 +6161,7 @@
           </a:bodyPr>
           <a:lstStyle/>
           <a:p>
-            <a:pPr algn="l" indent="0" marL="0">
+            <a:pPr marL="0" indent="0" algn="l">
               <a:lnSpc>
                 <a:spcPct val="150000"/>
               </a:lnSpc>
@@ -6243,6 +6201,13 @@
           </a:solidFill>
           <a:ln/>
         </p:spPr>
+        <p:txBody>
+          <a:bodyPr/>
+          <a:lstStyle/>
+          <a:p>
+            <a:endParaRPr lang="en-GB"/>
+          </a:p>
+        </p:txBody>
       </p:sp>
       <p:sp>
         <p:nvSpPr>
@@ -6267,7 +6232,7 @@
           </a:bodyPr>
           <a:lstStyle/>
           <a:p>
-            <a:pPr algn="l" indent="0" marL="0">
+            <a:pPr marL="0" indent="0" algn="l">
               <a:buNone/>
             </a:pPr>
             <a:r>
@@ -6308,7 +6273,7 @@
           </a:bodyPr>
           <a:lstStyle/>
           <a:p>
-            <a:pPr algn="l" indent="0" marL="0">
+            <a:pPr marL="0" indent="0" algn="l">
               <a:buNone/>
             </a:pPr>
             <a:r>
@@ -6349,7 +6314,7 @@
           </a:bodyPr>
           <a:lstStyle/>
           <a:p>
-            <a:pPr algn="l" indent="0" marL="0">
+            <a:pPr marL="0" indent="0" algn="l">
               <a:buNone/>
             </a:pPr>
             <a:r>
@@ -6668,4 +6633,319 @@
     </a:ext>
   </a:extLst>
 </a:theme>
+</file>
+
+<file path=ppt/theme/theme2.xml><?xml version="1.0" encoding="utf-8"?>
+<a:theme xmlns:a="http://schemas.openxmlformats.org/drawingml/2006/main" name="Office Theme">
+  <a:themeElements>
+    <a:clrScheme name="Office">
+      <a:dk1>
+        <a:sysClr val="windowText" lastClr="000000"/>
+      </a:dk1>
+      <a:lt1>
+        <a:sysClr val="window" lastClr="FFFFFF"/>
+      </a:lt1>
+      <a:dk2>
+        <a:srgbClr val="0E2841"/>
+      </a:dk2>
+      <a:lt2>
+        <a:srgbClr val="E8E8E8"/>
+      </a:lt2>
+      <a:accent1>
+        <a:srgbClr val="156082"/>
+      </a:accent1>
+      <a:accent2>
+        <a:srgbClr val="E97132"/>
+      </a:accent2>
+      <a:accent3>
+        <a:srgbClr val="196B24"/>
+      </a:accent3>
+      <a:accent4>
+        <a:srgbClr val="0F9ED5"/>
+      </a:accent4>
+      <a:accent5>
+        <a:srgbClr val="A02B93"/>
+      </a:accent5>
+      <a:accent6>
+        <a:srgbClr val="4EA72E"/>
+      </a:accent6>
+      <a:hlink>
+        <a:srgbClr val="467886"/>
+      </a:hlink>
+      <a:folHlink>
+        <a:srgbClr val="96607D"/>
+      </a:folHlink>
+    </a:clrScheme>
+    <a:fontScheme name="Office">
+      <a:majorFont>
+        <a:latin typeface="Aptos Display" panose="02110004020202020204"/>
+        <a:ea typeface=""/>
+        <a:cs typeface=""/>
+        <a:font script="Jpan" typeface="游ゴシック Light"/>
+        <a:font script="Hang" typeface="맑은 고딕"/>
+        <a:font script="Hans" typeface="等线 Light"/>
+        <a:font script="Hant" typeface="新細明體"/>
+        <a:font script="Arab" typeface="Times New Roman"/>
+        <a:font script="Hebr" typeface="Times New Roman"/>
+        <a:font script="Thai" typeface="Angsana New"/>
+        <a:font script="Ethi" typeface="Nyala"/>
+        <a:font script="Beng" typeface="Vrinda"/>
+        <a:font script="Gujr" typeface="Shruti"/>
+        <a:font script="Khmr" typeface="MoolBoran"/>
+        <a:font script="Knda" typeface="Tunga"/>
+        <a:font script="Guru" typeface="Raavi"/>
+        <a:font script="Cans" typeface="Euphemia"/>
+        <a:font script="Cher" typeface="Plantagenet Cherokee"/>
+        <a:font script="Yiii" typeface="Microsoft Yi Baiti"/>
+        <a:font script="Tibt" typeface="Microsoft Himalaya"/>
+        <a:font script="Thaa" typeface="MV Boli"/>
+        <a:font script="Deva" typeface="Mangal"/>
+        <a:font script="Telu" typeface="Gautami"/>
+        <a:font script="Taml" typeface="Latha"/>
+        <a:font script="Syrc" typeface="Estrangelo Edessa"/>
+        <a:font script="Orya" typeface="Kalinga"/>
+        <a:font script="Mlym" typeface="Kartika"/>
+        <a:font script="Laoo" typeface="DokChampa"/>
+        <a:font script="Sinh" typeface="Iskoola Pota"/>
+        <a:font script="Mong" typeface="Mongolian Baiti"/>
+        <a:font script="Viet" typeface="Times New Roman"/>
+        <a:font script="Uigh" typeface="Microsoft Uighur"/>
+        <a:font script="Geor" typeface="Sylfaen"/>
+        <a:font script="Armn" typeface="Arial"/>
+        <a:font script="Bugi" typeface="Leelawadee UI"/>
+        <a:font script="Bopo" typeface="Microsoft JhengHei"/>
+        <a:font script="Java" typeface="Javanese Text"/>
+        <a:font script="Lisu" typeface="Segoe UI"/>
+        <a:font script="Mymr" typeface="Myanmar Text"/>
+        <a:font script="Nkoo" typeface="Ebrima"/>
+        <a:font script="Olck" typeface="Nirmala UI"/>
+        <a:font script="Osma" typeface="Ebrima"/>
+        <a:font script="Phag" typeface="Phagspa"/>
+        <a:font script="Syrn" typeface="Estrangelo Edessa"/>
+        <a:font script="Syrj" typeface="Estrangelo Edessa"/>
+        <a:font script="Syre" typeface="Estrangelo Edessa"/>
+        <a:font script="Sora" typeface="Nirmala UI"/>
+        <a:font script="Tale" typeface="Microsoft Tai Le"/>
+        <a:font script="Talu" typeface="Microsoft New Tai Lue"/>
+        <a:font script="Tfng" typeface="Ebrima"/>
+      </a:majorFont>
+      <a:minorFont>
+        <a:latin typeface="Aptos" panose="02110004020202020204"/>
+        <a:ea typeface=""/>
+        <a:cs typeface=""/>
+        <a:font script="Jpan" typeface="游ゴシック"/>
+        <a:font script="Hang" typeface="맑은 고딕"/>
+        <a:font script="Hans" typeface="等线"/>
+        <a:font script="Hant" typeface="新細明體"/>
+        <a:font script="Arab" typeface="Arial"/>
+        <a:font script="Hebr" typeface="Arial"/>
+        <a:font script="Thai" typeface="Cordia New"/>
+        <a:font script="Ethi" typeface="Nyala"/>
+        <a:font script="Beng" typeface="Vrinda"/>
+        <a:font script="Gujr" typeface="Shruti"/>
+        <a:font script="Khmr" typeface="DaunPenh"/>
+        <a:font script="Knda" typeface="Tunga"/>
+        <a:font script="Guru" typeface="Raavi"/>
+        <a:font script="Cans" typeface="Euphemia"/>
+        <a:font script="Cher" typeface="Plantagenet Cherokee"/>
+        <a:font script="Yiii" typeface="Microsoft Yi Baiti"/>
+        <a:font script="Tibt" typeface="Microsoft Himalaya"/>
+        <a:font script="Thaa" typeface="MV Boli"/>
+        <a:font script="Deva" typeface="Mangal"/>
+        <a:font script="Telu" typeface="Gautami"/>
+        <a:font script="Taml" typeface="Latha"/>
+        <a:font script="Syrc" typeface="Estrangelo Edessa"/>
+        <a:font script="Orya" typeface="Kalinga"/>
+        <a:font script="Mlym" typeface="Kartika"/>
+        <a:font script="Laoo" typeface="DokChampa"/>
+        <a:font script="Sinh" typeface="Iskoola Pota"/>
+        <a:font script="Mong" typeface="Mongolian Baiti"/>
+        <a:font script="Viet" typeface="Arial"/>
+        <a:font script="Uigh" typeface="Microsoft Uighur"/>
+        <a:font script="Geor" typeface="Sylfaen"/>
+        <a:font script="Armn" typeface="Arial"/>
+        <a:font script="Bugi" typeface="Leelawadee UI"/>
+        <a:font script="Bopo" typeface="Microsoft JhengHei"/>
+        <a:font script="Java" typeface="Javanese Text"/>
+        <a:font script="Lisu" typeface="Segoe UI"/>
+        <a:font script="Mymr" typeface="Myanmar Text"/>
+        <a:font script="Nkoo" typeface="Ebrima"/>
+        <a:font script="Olck" typeface="Nirmala UI"/>
+        <a:font script="Osma" typeface="Ebrima"/>
+        <a:font script="Phag" typeface="Phagspa"/>
+        <a:font script="Syrn" typeface="Estrangelo Edessa"/>
+        <a:font script="Syrj" typeface="Estrangelo Edessa"/>
+        <a:font script="Syre" typeface="Estrangelo Edessa"/>
+        <a:font script="Sora" typeface="Nirmala UI"/>
+        <a:font script="Tale" typeface="Microsoft Tai Le"/>
+        <a:font script="Talu" typeface="Microsoft New Tai Lue"/>
+        <a:font script="Tfng" typeface="Ebrima"/>
+      </a:minorFont>
+    </a:fontScheme>
+    <a:fmtScheme name="Office">
+      <a:fillStyleLst>
+        <a:solidFill>
+          <a:schemeClr val="phClr"/>
+        </a:solidFill>
+        <a:gradFill rotWithShape="1">
+          <a:gsLst>
+            <a:gs pos="0">
+              <a:schemeClr val="phClr">
+                <a:lumMod val="110000"/>
+                <a:satMod val="105000"/>
+                <a:tint val="67000"/>
+              </a:schemeClr>
+            </a:gs>
+            <a:gs pos="50000">
+              <a:schemeClr val="phClr">
+                <a:lumMod val="105000"/>
+                <a:satMod val="103000"/>
+                <a:tint val="73000"/>
+              </a:schemeClr>
+            </a:gs>
+            <a:gs pos="100000">
+              <a:schemeClr val="phClr">
+                <a:lumMod val="105000"/>
+                <a:satMod val="109000"/>
+                <a:tint val="81000"/>
+              </a:schemeClr>
+            </a:gs>
+          </a:gsLst>
+          <a:lin ang="5400000" scaled="0"/>
+        </a:gradFill>
+        <a:gradFill rotWithShape="1">
+          <a:gsLst>
+            <a:gs pos="0">
+              <a:schemeClr val="phClr">
+                <a:satMod val="103000"/>
+                <a:lumMod val="102000"/>
+                <a:tint val="94000"/>
+              </a:schemeClr>
+            </a:gs>
+            <a:gs pos="50000">
+              <a:schemeClr val="phClr">
+                <a:satMod val="110000"/>
+                <a:lumMod val="100000"/>
+                <a:shade val="100000"/>
+              </a:schemeClr>
+            </a:gs>
+            <a:gs pos="100000">
+              <a:schemeClr val="phClr">
+                <a:lumMod val="99000"/>
+                <a:satMod val="120000"/>
+                <a:shade val="78000"/>
+              </a:schemeClr>
+            </a:gs>
+          </a:gsLst>
+          <a:lin ang="5400000" scaled="0"/>
+        </a:gradFill>
+      </a:fillStyleLst>
+      <a:lnStyleLst>
+        <a:ln w="12700" cap="flat" cmpd="sng" algn="ctr">
+          <a:solidFill>
+            <a:schemeClr val="phClr"/>
+          </a:solidFill>
+          <a:prstDash val="solid"/>
+          <a:miter lim="800000"/>
+        </a:ln>
+        <a:ln w="19050" cap="flat" cmpd="sng" algn="ctr">
+          <a:solidFill>
+            <a:schemeClr val="phClr"/>
+          </a:solidFill>
+          <a:prstDash val="solid"/>
+          <a:miter lim="800000"/>
+        </a:ln>
+        <a:ln w="25400" cap="flat" cmpd="sng" algn="ctr">
+          <a:solidFill>
+            <a:schemeClr val="phClr"/>
+          </a:solidFill>
+          <a:prstDash val="solid"/>
+          <a:miter lim="800000"/>
+        </a:ln>
+      </a:lnStyleLst>
+      <a:effectStyleLst>
+        <a:effectStyle>
+          <a:effectLst/>
+        </a:effectStyle>
+        <a:effectStyle>
+          <a:effectLst/>
+        </a:effectStyle>
+        <a:effectStyle>
+          <a:effectLst>
+            <a:outerShdw blurRad="57150" dist="19050" dir="5400000" algn="ctr" rotWithShape="0">
+              <a:srgbClr val="000000">
+                <a:alpha val="63000"/>
+              </a:srgbClr>
+            </a:outerShdw>
+          </a:effectLst>
+        </a:effectStyle>
+      </a:effectStyleLst>
+      <a:bgFillStyleLst>
+        <a:solidFill>
+          <a:schemeClr val="phClr"/>
+        </a:solidFill>
+        <a:solidFill>
+          <a:schemeClr val="phClr">
+            <a:tint val="95000"/>
+            <a:satMod val="170000"/>
+          </a:schemeClr>
+        </a:solidFill>
+        <a:gradFill rotWithShape="1">
+          <a:gsLst>
+            <a:gs pos="0">
+              <a:schemeClr val="phClr">
+                <a:tint val="93000"/>
+                <a:satMod val="150000"/>
+                <a:shade val="98000"/>
+                <a:lumMod val="102000"/>
+              </a:schemeClr>
+            </a:gs>
+            <a:gs pos="50000">
+              <a:schemeClr val="phClr">
+                <a:tint val="98000"/>
+                <a:satMod val="130000"/>
+                <a:shade val="90000"/>
+                <a:lumMod val="103000"/>
+              </a:schemeClr>
+            </a:gs>
+            <a:gs pos="100000">
+              <a:schemeClr val="phClr">
+                <a:shade val="63000"/>
+                <a:satMod val="120000"/>
+              </a:schemeClr>
+            </a:gs>
+          </a:gsLst>
+          <a:lin ang="5400000" scaled="0"/>
+        </a:gradFill>
+      </a:bgFillStyleLst>
+    </a:fmtScheme>
+  </a:themeElements>
+  <a:objectDefaults>
+    <a:lnDef>
+      <a:spPr/>
+      <a:bodyPr/>
+      <a:lstStyle/>
+      <a:style>
+        <a:lnRef idx="2">
+          <a:schemeClr val="accent1"/>
+        </a:lnRef>
+        <a:fillRef idx="0">
+          <a:schemeClr val="accent1"/>
+        </a:fillRef>
+        <a:effectRef idx="1">
+          <a:schemeClr val="accent1"/>
+        </a:effectRef>
+        <a:fontRef idx="minor">
+          <a:schemeClr val="tx1"/>
+        </a:fontRef>
+      </a:style>
+    </a:lnDef>
+  </a:objectDefaults>
+  <a:extraClrSchemeLst/>
+  <a:extLst>
+    <a:ext uri="{05A4C25C-085E-4340-85A3-A5531E510DB2}">
+      <thm15:themeFamily xmlns:thm15="http://schemas.microsoft.com/office/thememl/2012/main" name="Office Theme" id="{2E142A2C-CD16-42D6-873A-C26D2A0506FA}" vid="{1BDDFF52-6CD6-40A5-AB3C-68EB2F1E4D0A}"/>
+    </a:ext>
+  </a:extLst>
+</a:theme>
 </file>
</xml_diff>